<commit_message>
fix(slides): screen margins, 16:9 PowerPoint template, larger PDF page
- HTML/preview: inset section padding so paragraphs and headings no longer
  run to the slide edge (the print margin fix only covered the PDF).
- PPTX: the per-theme reference decks were 4:3 (10x7.5 in) while the decks
  are 16:9, so Pandoc laid 16:9 content into a 4:3 frame and the text
  shifted. make_reference_pptx now builds 16:9 widescreen references and
  widens the layout placeholders to fill them; all nine regenerated.
- PDF: the 16:9 page reveal emits reads small; the finished vector PDF is
  scaled to the 13.333x7.5 in PowerPoint widescreen width (crisp, aspect
  preserved).

Release v0.1.3.
</commit_message>
<xml_diff>
--- a/src/epy_slides/assets/reference_pptx/academic.pptx
+++ b/src/epy_slides/assets/reference_pptx/academic.pptx
@@ -4,7 +4,7 @@
   <p:sldMasterIdLst>
     <p:sldMasterId id="2147483648" r:id="rId1"/>
   </p:sldMasterIdLst>
-  <p:sldSz cx="9144000" cy="6858000" type="screen4x3"/>
+  <p:sldSz cx="12192000" cy="6858000" type="screen4x3"/>
   <p:notesSz cx="6858000" cy="9144000"/>
   <p:defaultTextStyle>
     <a:defPPr>
@@ -133,8 +133,8 @@
         </p:nvSpPr>
         <p:spPr>
           <a:xfrm>
-            <a:off x="685800" y="2130425"/>
-            <a:ext cx="7772400" cy="1470025"/>
+            <a:off x="914400" y="2130425"/>
+            <a:ext cx="10363200" cy="1470025"/>
           </a:xfrm>
         </p:spPr>
         <p:txBody>
@@ -161,8 +161,8 @@
         </p:nvSpPr>
         <p:spPr>
           <a:xfrm>
-            <a:off x="1371600" y="3886200"/>
-            <a:ext cx="6400800" cy="1752600"/>
+            <a:off x="1828800" y="3886200"/>
+            <a:ext cx="8534400" cy="1752600"/>
           </a:xfrm>
         </p:spPr>
         <p:txBody>
@@ -545,8 +545,8 @@
         </p:nvSpPr>
         <p:spPr>
           <a:xfrm>
-            <a:off x="6629400" y="274638"/>
-            <a:ext cx="2057400" cy="5851525"/>
+            <a:off x="8839200" y="274638"/>
+            <a:ext cx="2743200" cy="5851525"/>
           </a:xfrm>
         </p:spPr>
         <p:txBody>
@@ -573,8 +573,8 @@
         </p:nvSpPr>
         <p:spPr>
           <a:xfrm>
-            <a:off x="457200" y="274638"/>
-            <a:ext cx="6019800" cy="5851525"/>
+            <a:off x="609600" y="274638"/>
+            <a:ext cx="8026400" cy="5851525"/>
           </a:xfrm>
         </p:spPr>
         <p:txBody>
@@ -895,8 +895,8 @@
         </p:nvSpPr>
         <p:spPr>
           <a:xfrm>
-            <a:off x="722313" y="4406900"/>
-            <a:ext cx="7772400" cy="1362075"/>
+            <a:off x="963084" y="4406900"/>
+            <a:ext cx="10363200" cy="1362075"/>
           </a:xfrm>
         </p:spPr>
         <p:txBody>
@@ -927,8 +927,8 @@
         </p:nvSpPr>
         <p:spPr>
           <a:xfrm>
-            <a:off x="722313" y="2906713"/>
-            <a:ext cx="7772400" cy="1500187"/>
+            <a:off x="963084" y="2906713"/>
+            <a:ext cx="10363200" cy="1500187"/>
           </a:xfrm>
         </p:spPr>
         <p:txBody>
@@ -1164,8 +1164,8 @@
         </p:nvSpPr>
         <p:spPr>
           <a:xfrm>
-            <a:off x="457200" y="1600200"/>
-            <a:ext cx="4038600" cy="4525963"/>
+            <a:off x="609600" y="1600200"/>
+            <a:ext cx="5384800" cy="4525963"/>
           </a:xfrm>
         </p:spPr>
         <p:txBody>
@@ -1249,8 +1249,8 @@
         </p:nvSpPr>
         <p:spPr>
           <a:xfrm>
-            <a:off x="4648200" y="1600200"/>
-            <a:ext cx="4038600" cy="4525963"/>
+            <a:off x="6197600" y="1600200"/>
+            <a:ext cx="5384800" cy="4525963"/>
           </a:xfrm>
         </p:spPr>
         <p:txBody>
@@ -1456,8 +1456,8 @@
         </p:nvSpPr>
         <p:spPr>
           <a:xfrm>
-            <a:off x="457200" y="1535113"/>
-            <a:ext cx="4040188" cy="639762"/>
+            <a:off x="609600" y="1535113"/>
+            <a:ext cx="5386917" cy="639762"/>
           </a:xfrm>
         </p:spPr>
         <p:txBody>
@@ -1521,8 +1521,8 @@
         </p:nvSpPr>
         <p:spPr>
           <a:xfrm>
-            <a:off x="457200" y="2174875"/>
-            <a:ext cx="4040188" cy="3951288"/>
+            <a:off x="609600" y="2174875"/>
+            <a:ext cx="5386917" cy="3951288"/>
           </a:xfrm>
         </p:spPr>
         <p:txBody>
@@ -1606,8 +1606,8 @@
         </p:nvSpPr>
         <p:spPr>
           <a:xfrm>
-            <a:off x="4645025" y="1535113"/>
-            <a:ext cx="4041775" cy="639762"/>
+            <a:off x="6193366" y="1535113"/>
+            <a:ext cx="5389033" cy="639762"/>
           </a:xfrm>
         </p:spPr>
         <p:txBody>
@@ -1671,8 +1671,8 @@
         </p:nvSpPr>
         <p:spPr>
           <a:xfrm>
-            <a:off x="4645025" y="2174875"/>
-            <a:ext cx="4041775" cy="3951288"/>
+            <a:off x="6193366" y="2174875"/>
+            <a:ext cx="5389033" cy="3951288"/>
           </a:xfrm>
         </p:spPr>
         <p:txBody>
@@ -2064,8 +2064,8 @@
         </p:nvSpPr>
         <p:spPr>
           <a:xfrm>
-            <a:off x="457200" y="273050"/>
-            <a:ext cx="3008313" cy="1162050"/>
+            <a:off x="609600" y="273050"/>
+            <a:ext cx="4011084" cy="1162050"/>
           </a:xfrm>
         </p:spPr>
         <p:txBody>
@@ -2096,8 +2096,8 @@
         </p:nvSpPr>
         <p:spPr>
           <a:xfrm>
-            <a:off x="3575050" y="273050"/>
-            <a:ext cx="5111750" cy="5853113"/>
+            <a:off x="4766733" y="273050"/>
+            <a:ext cx="6815666" cy="5853113"/>
           </a:xfrm>
         </p:spPr>
         <p:txBody>
@@ -2181,8 +2181,8 @@
         </p:nvSpPr>
         <p:spPr>
           <a:xfrm>
-            <a:off x="457200" y="1435100"/>
-            <a:ext cx="3008313" cy="4691063"/>
+            <a:off x="609600" y="1435100"/>
+            <a:ext cx="4011084" cy="4691063"/>
           </a:xfrm>
         </p:spPr>
         <p:txBody>
@@ -2341,8 +2341,8 @@
         </p:nvSpPr>
         <p:spPr>
           <a:xfrm>
-            <a:off x="1792288" y="4800600"/>
-            <a:ext cx="5486400" cy="566738"/>
+            <a:off x="2389717" y="4800600"/>
+            <a:ext cx="7315200" cy="566738"/>
           </a:xfrm>
         </p:spPr>
         <p:txBody>
@@ -2373,8 +2373,8 @@
         </p:nvSpPr>
         <p:spPr>
           <a:xfrm>
-            <a:off x="1792288" y="612775"/>
-            <a:ext cx="5486400" cy="4114800"/>
+            <a:off x="2389717" y="612775"/>
+            <a:ext cx="7315200" cy="4114800"/>
           </a:xfrm>
         </p:spPr>
         <p:txBody>
@@ -2434,8 +2434,8 @@
         </p:nvSpPr>
         <p:spPr>
           <a:xfrm>
-            <a:off x="1792288" y="5367338"/>
-            <a:ext cx="5486400" cy="804862"/>
+            <a:off x="2389717" y="5367338"/>
+            <a:ext cx="7315200" cy="804862"/>
           </a:xfrm>
         </p:spPr>
         <p:txBody>
@@ -2599,8 +2599,8 @@
         </p:nvSpPr>
         <p:spPr>
           <a:xfrm>
-            <a:off x="457200" y="274638"/>
-            <a:ext cx="8229600" cy="1143000"/>
+            <a:off x="609600" y="274638"/>
+            <a:ext cx="10972800" cy="1143000"/>
           </a:xfrm>
           <a:prstGeom prst="rect">
             <a:avLst/>
@@ -2632,8 +2632,8 @@
         </p:nvSpPr>
         <p:spPr>
           <a:xfrm>
-            <a:off x="457200" y="1600200"/>
-            <a:ext cx="8229600" cy="4525963"/>
+            <a:off x="609600" y="1600200"/>
+            <a:ext cx="10972800" cy="4525963"/>
           </a:xfrm>
           <a:prstGeom prst="rect">
             <a:avLst/>
@@ -2694,8 +2694,8 @@
         </p:nvSpPr>
         <p:spPr>
           <a:xfrm>
-            <a:off x="457200" y="6356350"/>
-            <a:ext cx="2133600" cy="365125"/>
+            <a:off x="609600" y="6356350"/>
+            <a:ext cx="2844800" cy="365125"/>
           </a:xfrm>
           <a:prstGeom prst="rect">
             <a:avLst/>
@@ -2735,8 +2735,8 @@
         </p:nvSpPr>
         <p:spPr>
           <a:xfrm>
-            <a:off x="3124200" y="6356350"/>
-            <a:ext cx="2895600" cy="365125"/>
+            <a:off x="4165600" y="6356350"/>
+            <a:ext cx="3860800" cy="365125"/>
           </a:xfrm>
           <a:prstGeom prst="rect">
             <a:avLst/>
@@ -2772,8 +2772,8 @@
         </p:nvSpPr>
         <p:spPr>
           <a:xfrm>
-            <a:off x="6553200" y="6356350"/>
-            <a:ext cx="2133600" cy="365125"/>
+            <a:off x="8737600" y="6356350"/>
+            <a:ext cx="2844800" cy="365125"/>
           </a:xfrm>
           <a:prstGeom prst="rect">
             <a:avLst/>

</xml_diff>